<commit_message>
Pitch y README para la versión de Solana: deck sin Stellar y links a verifire-solana.cosmosapp.lat
</commit_message>
<xml_diff>
--- a/PITCH/Diapositivas VeriFire.pptx
+++ b/PITCH/Diapositivas VeriFire.pptx
@@ -7703,7 +7703,7 @@
                 <a:cs typeface="Nunito"/>
                 <a:sym typeface="Nunito"/>
               </a:rPr>
-              <a:t>Vincule sus activos físicos con tokens digitales infalsificables respaldados por la red Stellar.</a:t>
+              <a:t>Vincule sus activos físicos con tokens digitales infalsificables respaldados por la red Solana.</a:t>
             </a:r>
             <a:endParaRPr b="0" sz="1500">
               <a:solidFill>
@@ -9815,7 +9815,7 @@
                   <a:cs typeface="Nunito"/>
                   <a:sym typeface="Nunito"/>
                 </a:rPr>
-                <a:t>Costo de red Stellar</a:t>
+                <a:t>Comisión de red en Solana</a:t>
               </a:r>
               <a:endParaRPr b="1" sz="1500">
                 <a:solidFill>

</xml_diff>